<commit_message>
Fix text visibility on dark slides 1, 11, and 12
Three root causes fixed:
1. darkBg() now uses solid #0C0818 instead of gradient — PowerPoint
   gradient fills can cause rendering inconsistencies
2. Slide 11 stat boxes changed from 78%-transparent fills (almost
   invisible on dark bg) to solid #1E1040 boxes with coloured top
   accent bars; all text forced to FFFFFF / E2E8F0
3. Slide 12 contact boxes changed from white/88%-transparency
   (renders near-black, making white text vanish) to solid #1E1040
4. darkFooter uses solid #1E1040 strip instead of purpleDeep/40%
5. All secondary text on dark slides normalised to FFFFFF or E9D5FF

https://claude.ai/code/session_01ULuS7zriwA4qk6vRYb8xau
</commit_message>
<xml_diff>
--- a/public/WeThink-Company-Profile-2025.pptx
+++ b/public/WeThink-Company-Profile-2025.pptx
@@ -1861,6 +1861,9 @@
           <a:prstGeom prst="rect">
             <a:avLst/>
           </a:prstGeom>
+          <a:solidFill>
+            <a:srgbClr val="0C0818"/>
+          </a:solidFill>
           <a:ln/>
         </p:spPr>
       </p:sp>
@@ -2009,7 +2012,7 @@
             <a:r>
               <a:rPr lang="en-US" sz="7200" b="1" dirty="0">
                 <a:solidFill>
-                  <a:srgbClr val="C4B5FD"/>
+                  <a:srgbClr val="E9D5FF"/>
                 </a:solidFill>
               </a:rPr>
               <a:t>Think</a:t>
@@ -2033,7 +2036,7 @@
             <a:avLst/>
           </a:prstGeom>
           <a:solidFill>
-            <a:srgbClr val="D8B4FE"/>
+            <a:srgbClr val="FFFFFF"/>
           </a:solidFill>
           <a:ln w="12700">
             <a:solidFill>
@@ -2072,7 +2075,7 @@
             <a:r>
               <a:rPr lang="en-US" sz="1200" i="1" dirty="0">
                 <a:solidFill>
-                  <a:srgbClr val="E2E8F0"/>
+                  <a:srgbClr val="FFFFFF"/>
                 </a:solidFill>
               </a:rPr>
               <a:t>Engineered for the Digital Age.</a:t>
@@ -2108,7 +2111,7 @@
             <a:r>
               <a:rPr lang="en-US" sz="950" dirty="0">
                 <a:solidFill>
-                  <a:srgbClr val="D8B4FE"/>
+                  <a:srgbClr val="E9D5FF"/>
                 </a:solidFill>
               </a:rPr>
               <a:t>Abu Dhabi, UAE  ·  Est. 2019  ·  wethink.ae</a:t>
@@ -2132,7 +2135,7 @@
             <a:avLst/>
           </a:prstGeom>
           <a:solidFill>
-            <a:srgbClr val="D8B4FE"/>
+            <a:srgbClr val="FFFFFF"/>
           </a:solidFill>
           <a:ln w="12700">
             <a:solidFill>
@@ -2171,7 +2174,7 @@
             <a:r>
               <a:rPr lang="en-US" sz="950" dirty="0">
                 <a:solidFill>
-                  <a:srgbClr val="E2E8F0"/>
+                  <a:srgbClr val="FFFFFF"/>
                 </a:solidFill>
               </a:rPr>
               <a:t>IT Consulting</a:t>
@@ -2195,7 +2198,7 @@
             <a:avLst/>
           </a:prstGeom>
           <a:solidFill>
-            <a:srgbClr val="D8B4FE"/>
+            <a:srgbClr val="FFFFFF"/>
           </a:solidFill>
           <a:ln w="12700">
             <a:solidFill>
@@ -2234,7 +2237,7 @@
             <a:r>
               <a:rPr lang="en-US" sz="950" dirty="0">
                 <a:solidFill>
-                  <a:srgbClr val="E2E8F0"/>
+                  <a:srgbClr val="FFFFFF"/>
                 </a:solidFill>
               </a:rPr>
               <a:t>Cloud Strategy</a:t>
@@ -2258,7 +2261,7 @@
             <a:avLst/>
           </a:prstGeom>
           <a:solidFill>
-            <a:srgbClr val="D8B4FE"/>
+            <a:srgbClr val="FFFFFF"/>
           </a:solidFill>
           <a:ln w="12700">
             <a:solidFill>
@@ -2297,7 +2300,7 @@
             <a:r>
               <a:rPr lang="en-US" sz="950" dirty="0">
                 <a:solidFill>
-                  <a:srgbClr val="E2E8F0"/>
+                  <a:srgbClr val="FFFFFF"/>
                 </a:solidFill>
               </a:rPr>
               <a:t>Cybersecurity</a:t>
@@ -2321,7 +2324,7 @@
             <a:avLst/>
           </a:prstGeom>
           <a:solidFill>
-            <a:srgbClr val="D8B4FE"/>
+            <a:srgbClr val="FFFFFF"/>
           </a:solidFill>
           <a:ln w="12700">
             <a:solidFill>
@@ -2360,7 +2363,7 @@
             <a:r>
               <a:rPr lang="en-US" sz="950" dirty="0">
                 <a:solidFill>
-                  <a:srgbClr val="E2E8F0"/>
+                  <a:srgbClr val="FFFFFF"/>
                 </a:solidFill>
               </a:rPr>
               <a:t>Custom Software</a:t>
@@ -2496,9 +2499,7 @@
             <a:avLst/>
           </a:prstGeom>
           <a:solidFill>
-            <a:srgbClr val="3B0764">
-              <a:alpha val="60000"/>
-            </a:srgbClr>
+            <a:srgbClr val="1E1040"/>
           </a:solidFill>
           <a:ln w="12700">
             <a:solidFill>
@@ -2537,7 +2538,7 @@
             <a:r>
               <a:rPr lang="en-US" sz="750" dirty="0">
                 <a:solidFill>
-                  <a:srgbClr val="C4B5FD"/>
+                  <a:srgbClr val="E9D5FF"/>
                 </a:solidFill>
               </a:rPr>
               <a:t>WeThink Technology Consulting  ·  Abu Dhabi, UAE  ·  wethink.ae  ·  © 2025</a:t>
@@ -3538,6 +3539,9 @@
           <a:prstGeom prst="rect">
             <a:avLst/>
           </a:prstGeom>
+          <a:solidFill>
+            <a:srgbClr val="0C0818"/>
+          </a:solidFill>
           <a:ln/>
         </p:spPr>
       </p:sp>
@@ -3638,7 +3642,7 @@
             <a:avLst/>
           </a:prstGeom>
           <a:solidFill>
-            <a:srgbClr val="C4B5FD"/>
+            <a:srgbClr val="FFFFFF"/>
           </a:solidFill>
           <a:ln w="12700">
             <a:solidFill>
@@ -3677,7 +3681,7 @@
             <a:r>
               <a:rPr lang="en-US" sz="750" b="1" spc="200" kern="0" dirty="0">
                 <a:solidFill>
-                  <a:srgbClr val="C4B5FD"/>
+                  <a:srgbClr val="FFFFFF"/>
                 </a:solidFill>
               </a:rPr>
               <a:t>BY THE NUMBERS</a:t>
@@ -3749,7 +3753,7 @@
             <a:r>
               <a:rPr lang="en-US" sz="4400" b="1" dirty="0">
                 <a:solidFill>
-                  <a:srgbClr val="C4B5FD"/>
+                  <a:srgbClr val="E9D5FF"/>
                 </a:solidFill>
               </a:rPr>
               <a:t>Define Us</a:t>
@@ -3775,14 +3779,12 @@
             </a:avLst>
           </a:prstGeom>
           <a:solidFill>
-            <a:srgbClr val="A78BFA">
-              <a:alpha val="22000"/>
-            </a:srgbClr>
+            <a:srgbClr val="1E1040"/>
           </a:solidFill>
           <a:ln w="12700">
             <a:solidFill>
-              <a:srgbClr val="A78BFA">
-                <a:alpha val="55000"/>
+              <a:srgbClr val="7C3AED">
+                <a:alpha val="80000"/>
               </a:srgbClr>
             </a:solidFill>
             <a:prstDash val="solid"/>
@@ -3791,506 +3793,20 @@
       </p:sp>
       <p:sp>
         <p:nvSpPr>
-          <p:cNvPr id="11" name="Text 9"/>
-          <p:cNvSpPr/>
-          <p:nvPr/>
-        </p:nvSpPr>
-        <p:spPr>
-          <a:xfrm>
-            <a:off x="662940" y="1901952"/>
-            <a:ext cx="2084832" cy="713232"/>
-          </a:xfrm>
-          <a:prstGeom prst="rect">
-            <a:avLst/>
-          </a:prstGeom>
-          <a:noFill/>
-          <a:ln/>
-        </p:spPr>
-        <p:txBody>
-          <a:bodyPr wrap="square" rtlCol="0" anchor="ctr"/>
-          <a:lstStyle/>
-          <a:p>
-            <a:pPr algn="ctr" indent="0" marL="0">
-              <a:buNone/>
-            </a:pPr>
-            <a:r>
-              <a:rPr lang="en-US" sz="3400" b="1" dirty="0">
-                <a:solidFill>
-                  <a:srgbClr val="FFFFFF"/>
-                </a:solidFill>
-              </a:rPr>
-              <a:t>5+</a:t>
-            </a:r>
-            <a:endParaRPr lang="en-US" sz="3400" dirty="0"/>
-          </a:p>
-        </p:txBody>
-      </p:sp>
-      <p:sp>
-        <p:nvSpPr>
-          <p:cNvPr id="12" name="Text 10"/>
-          <p:cNvSpPr/>
-          <p:nvPr/>
-        </p:nvSpPr>
-        <p:spPr>
-          <a:xfrm>
-            <a:off x="662940" y="2615184"/>
-            <a:ext cx="2084832" cy="530352"/>
-          </a:xfrm>
-          <a:prstGeom prst="rect">
-            <a:avLst/>
-          </a:prstGeom>
-          <a:noFill/>
-          <a:ln/>
-        </p:spPr>
-        <p:txBody>
-          <a:bodyPr wrap="square" rtlCol="0" anchor="ctr"/>
-          <a:lstStyle/>
-          <a:p>
-            <a:pPr algn="ctr" indent="0" marL="0">
-              <a:buNone/>
-            </a:pPr>
-            <a:r>
-              <a:rPr lang="en-US" sz="900" dirty="0">
-                <a:solidFill>
-                  <a:srgbClr val="CBD5E1"/>
-                </a:solidFill>
-              </a:rPr>
-              <a:t>Years of Excellence</a:t>
-            </a:r>
-            <a:endParaRPr lang="en-US" sz="900" dirty="0"/>
-          </a:p>
-        </p:txBody>
-      </p:sp>
-      <p:sp>
-        <p:nvSpPr>
-          <p:cNvPr id="13" name="Shape 11"/>
-          <p:cNvSpPr/>
-          <p:nvPr/>
-        </p:nvSpPr>
-        <p:spPr>
-          <a:xfrm>
-            <a:off x="2857500" y="1828800"/>
-            <a:ext cx="2084832" cy="1444752"/>
-          </a:xfrm>
-          <a:prstGeom prst="rect">
-            <a:avLst>
-              <a:gd name="adj" fmla="val 7595"/>
-            </a:avLst>
-          </a:prstGeom>
-          <a:solidFill>
-            <a:srgbClr val="818CF8">
-              <a:alpha val="22000"/>
-            </a:srgbClr>
-          </a:solidFill>
-          <a:ln w="12700">
-            <a:solidFill>
-              <a:srgbClr val="818CF8">
-                <a:alpha val="55000"/>
-              </a:srgbClr>
-            </a:solidFill>
-            <a:prstDash val="solid"/>
-          </a:ln>
-        </p:spPr>
-      </p:sp>
-      <p:sp>
-        <p:nvSpPr>
-          <p:cNvPr id="14" name="Text 12"/>
-          <p:cNvSpPr/>
-          <p:nvPr/>
-        </p:nvSpPr>
-        <p:spPr>
-          <a:xfrm>
-            <a:off x="2857500" y="1901952"/>
-            <a:ext cx="2084832" cy="713232"/>
-          </a:xfrm>
-          <a:prstGeom prst="rect">
-            <a:avLst/>
-          </a:prstGeom>
-          <a:noFill/>
-          <a:ln/>
-        </p:spPr>
-        <p:txBody>
-          <a:bodyPr wrap="square" rtlCol="0" anchor="ctr"/>
-          <a:lstStyle/>
-          <a:p>
-            <a:pPr algn="ctr" indent="0" marL="0">
-              <a:buNone/>
-            </a:pPr>
-            <a:r>
-              <a:rPr lang="en-US" sz="3400" b="1" dirty="0">
-                <a:solidFill>
-                  <a:srgbClr val="FFFFFF"/>
-                </a:solidFill>
-              </a:rPr>
-              <a:t>5,000+</a:t>
-            </a:r>
-            <a:endParaRPr lang="en-US" sz="3400" dirty="0"/>
-          </a:p>
-        </p:txBody>
-      </p:sp>
-      <p:sp>
-        <p:nvSpPr>
-          <p:cNvPr id="15" name="Text 13"/>
-          <p:cNvSpPr/>
-          <p:nvPr/>
-        </p:nvSpPr>
-        <p:spPr>
-          <a:xfrm>
-            <a:off x="2857500" y="2615184"/>
-            <a:ext cx="2084832" cy="530352"/>
-          </a:xfrm>
-          <a:prstGeom prst="rect">
-            <a:avLst/>
-          </a:prstGeom>
-          <a:noFill/>
-          <a:ln/>
-        </p:spPr>
-        <p:txBody>
-          <a:bodyPr wrap="square" rtlCol="0" anchor="ctr"/>
-          <a:lstStyle/>
-          <a:p>
-            <a:pPr algn="ctr" indent="0" marL="0">
-              <a:buNone/>
-            </a:pPr>
-            <a:r>
-              <a:rPr lang="en-US" sz="900" dirty="0">
-                <a:solidFill>
-                  <a:srgbClr val="CBD5E1"/>
-                </a:solidFill>
-              </a:rPr>
-              <a:t>Projects Delivered</a:t>
-            </a:r>
-            <a:endParaRPr lang="en-US" sz="900" dirty="0"/>
-          </a:p>
-        </p:txBody>
-      </p:sp>
-      <p:sp>
-        <p:nvSpPr>
-          <p:cNvPr id="16" name="Shape 14"/>
-          <p:cNvSpPr/>
-          <p:nvPr/>
-        </p:nvSpPr>
-        <p:spPr>
-          <a:xfrm>
-            <a:off x="5052060" y="1828800"/>
-            <a:ext cx="2084832" cy="1444752"/>
-          </a:xfrm>
-          <a:prstGeom prst="rect">
-            <a:avLst>
-              <a:gd name="adj" fmla="val 7595"/>
-            </a:avLst>
-          </a:prstGeom>
-          <a:solidFill>
-            <a:srgbClr val="38BDF8">
-              <a:alpha val="22000"/>
-            </a:srgbClr>
-          </a:solidFill>
-          <a:ln w="12700">
-            <a:solidFill>
-              <a:srgbClr val="38BDF8">
-                <a:alpha val="55000"/>
-              </a:srgbClr>
-            </a:solidFill>
-            <a:prstDash val="solid"/>
-          </a:ln>
-        </p:spPr>
-      </p:sp>
-      <p:sp>
-        <p:nvSpPr>
-          <p:cNvPr id="17" name="Text 15"/>
-          <p:cNvSpPr/>
-          <p:nvPr/>
-        </p:nvSpPr>
-        <p:spPr>
-          <a:xfrm>
-            <a:off x="5052060" y="1901952"/>
-            <a:ext cx="2084832" cy="713232"/>
-          </a:xfrm>
-          <a:prstGeom prst="rect">
-            <a:avLst/>
-          </a:prstGeom>
-          <a:noFill/>
-          <a:ln/>
-        </p:spPr>
-        <p:txBody>
-          <a:bodyPr wrap="square" rtlCol="0" anchor="ctr"/>
-          <a:lstStyle/>
-          <a:p>
-            <a:pPr algn="ctr" indent="0" marL="0">
-              <a:buNone/>
-            </a:pPr>
-            <a:r>
-              <a:rPr lang="en-US" sz="3400" b="1" dirty="0">
-                <a:solidFill>
-                  <a:srgbClr val="FFFFFF"/>
-                </a:solidFill>
-              </a:rPr>
-              <a:t>1,000+</a:t>
-            </a:r>
-            <a:endParaRPr lang="en-US" sz="3400" dirty="0"/>
-          </a:p>
-        </p:txBody>
-      </p:sp>
-      <p:sp>
-        <p:nvSpPr>
-          <p:cNvPr id="18" name="Text 16"/>
-          <p:cNvSpPr/>
-          <p:nvPr/>
-        </p:nvSpPr>
-        <p:spPr>
-          <a:xfrm>
-            <a:off x="5052060" y="2615184"/>
-            <a:ext cx="2084832" cy="530352"/>
-          </a:xfrm>
-          <a:prstGeom prst="rect">
-            <a:avLst/>
-          </a:prstGeom>
-          <a:noFill/>
-          <a:ln/>
-        </p:spPr>
-        <p:txBody>
-          <a:bodyPr wrap="square" rtlCol="0" anchor="ctr"/>
-          <a:lstStyle/>
-          <a:p>
-            <a:pPr algn="ctr" indent="0" marL="0">
-              <a:buNone/>
-            </a:pPr>
-            <a:r>
-              <a:rPr lang="en-US" sz="900" dirty="0">
-                <a:solidFill>
-                  <a:srgbClr val="CBD5E1"/>
-                </a:solidFill>
-              </a:rPr>
-              <a:t>Clients Served</a:t>
-            </a:r>
-            <a:endParaRPr lang="en-US" sz="900" dirty="0"/>
-          </a:p>
-        </p:txBody>
-      </p:sp>
-      <p:sp>
-        <p:nvSpPr>
-          <p:cNvPr id="19" name="Shape 17"/>
-          <p:cNvSpPr/>
-          <p:nvPr/>
-        </p:nvSpPr>
-        <p:spPr>
-          <a:xfrm>
-            <a:off x="7246620" y="1828800"/>
-            <a:ext cx="2084832" cy="1444752"/>
-          </a:xfrm>
-          <a:prstGeom prst="rect">
-            <a:avLst>
-              <a:gd name="adj" fmla="val 7595"/>
-            </a:avLst>
-          </a:prstGeom>
-          <a:solidFill>
-            <a:srgbClr val="34D399">
-              <a:alpha val="22000"/>
-            </a:srgbClr>
-          </a:solidFill>
-          <a:ln w="12700">
-            <a:solidFill>
-              <a:srgbClr val="34D399">
-                <a:alpha val="55000"/>
-              </a:srgbClr>
-            </a:solidFill>
-            <a:prstDash val="solid"/>
-          </a:ln>
-        </p:spPr>
-      </p:sp>
-      <p:sp>
-        <p:nvSpPr>
-          <p:cNvPr id="20" name="Text 18"/>
-          <p:cNvSpPr/>
-          <p:nvPr/>
-        </p:nvSpPr>
-        <p:spPr>
-          <a:xfrm>
-            <a:off x="7246620" y="1901952"/>
-            <a:ext cx="2084832" cy="713232"/>
-          </a:xfrm>
-          <a:prstGeom prst="rect">
-            <a:avLst/>
-          </a:prstGeom>
-          <a:noFill/>
-          <a:ln/>
-        </p:spPr>
-        <p:txBody>
-          <a:bodyPr wrap="square" rtlCol="0" anchor="ctr"/>
-          <a:lstStyle/>
-          <a:p>
-            <a:pPr algn="ctr" indent="0" marL="0">
-              <a:buNone/>
-            </a:pPr>
-            <a:r>
-              <a:rPr lang="en-US" sz="3400" b="1" dirty="0">
-                <a:solidFill>
-                  <a:srgbClr val="FFFFFF"/>
-                </a:solidFill>
-              </a:rPr>
-              <a:t>99.98%</a:t>
-            </a:r>
-            <a:endParaRPr lang="en-US" sz="3400" dirty="0"/>
-          </a:p>
-        </p:txBody>
-      </p:sp>
-      <p:sp>
-        <p:nvSpPr>
-          <p:cNvPr id="21" name="Text 19"/>
-          <p:cNvSpPr/>
-          <p:nvPr/>
-        </p:nvSpPr>
-        <p:spPr>
-          <a:xfrm>
-            <a:off x="7246620" y="2615184"/>
-            <a:ext cx="2084832" cy="530352"/>
-          </a:xfrm>
-          <a:prstGeom prst="rect">
-            <a:avLst/>
-          </a:prstGeom>
-          <a:noFill/>
-          <a:ln/>
-        </p:spPr>
-        <p:txBody>
-          <a:bodyPr wrap="square" rtlCol="0" anchor="ctr"/>
-          <a:lstStyle/>
-          <a:p>
-            <a:pPr algn="ctr" indent="0" marL="0">
-              <a:buNone/>
-            </a:pPr>
-            <a:r>
-              <a:rPr lang="en-US" sz="900" dirty="0">
-                <a:solidFill>
-                  <a:srgbClr val="CBD5E1"/>
-                </a:solidFill>
-              </a:rPr>
-              <a:t>Average Uptime SLA</a:t>
-            </a:r>
-            <a:endParaRPr lang="en-US" sz="900" dirty="0"/>
-          </a:p>
-        </p:txBody>
-      </p:sp>
-      <p:sp>
-        <p:nvSpPr>
-          <p:cNvPr id="22" name="Shape 20"/>
-          <p:cNvSpPr/>
-          <p:nvPr/>
-        </p:nvSpPr>
-        <p:spPr>
-          <a:xfrm>
-            <a:off x="9441180" y="1828800"/>
-            <a:ext cx="2084832" cy="1444752"/>
-          </a:xfrm>
-          <a:prstGeom prst="rect">
-            <a:avLst>
-              <a:gd name="adj" fmla="val 7595"/>
-            </a:avLst>
-          </a:prstGeom>
-          <a:solidFill>
-            <a:srgbClr val="FBB124">
-              <a:alpha val="22000"/>
-            </a:srgbClr>
-          </a:solidFill>
-          <a:ln w="12700">
-            <a:solidFill>
-              <a:srgbClr val="FBB124">
-                <a:alpha val="55000"/>
-              </a:srgbClr>
-            </a:solidFill>
-            <a:prstDash val="solid"/>
-          </a:ln>
-        </p:spPr>
-      </p:sp>
-      <p:sp>
-        <p:nvSpPr>
-          <p:cNvPr id="23" name="Text 21"/>
-          <p:cNvSpPr/>
-          <p:nvPr/>
-        </p:nvSpPr>
-        <p:spPr>
-          <a:xfrm>
-            <a:off x="9441180" y="1901952"/>
-            <a:ext cx="2084832" cy="713232"/>
-          </a:xfrm>
-          <a:prstGeom prst="rect">
-            <a:avLst/>
-          </a:prstGeom>
-          <a:noFill/>
-          <a:ln/>
-        </p:spPr>
-        <p:txBody>
-          <a:bodyPr wrap="square" rtlCol="0" anchor="ctr"/>
-          <a:lstStyle/>
-          <a:p>
-            <a:pPr algn="ctr" indent="0" marL="0">
-              <a:buNone/>
-            </a:pPr>
-            <a:r>
-              <a:rPr lang="en-US" sz="3400" b="1" dirty="0">
-                <a:solidFill>
-                  <a:srgbClr val="FFFFFF"/>
-                </a:solidFill>
-              </a:rPr>
-              <a:t>8</a:t>
-            </a:r>
-            <a:endParaRPr lang="en-US" sz="3400" dirty="0"/>
-          </a:p>
-        </p:txBody>
-      </p:sp>
-      <p:sp>
-        <p:nvSpPr>
-          <p:cNvPr id="24" name="Text 22"/>
-          <p:cNvSpPr/>
-          <p:nvPr/>
-        </p:nvSpPr>
-        <p:spPr>
-          <a:xfrm>
-            <a:off x="9441180" y="2615184"/>
-            <a:ext cx="2084832" cy="530352"/>
-          </a:xfrm>
-          <a:prstGeom prst="rect">
-            <a:avLst/>
-          </a:prstGeom>
-          <a:noFill/>
-          <a:ln/>
-        </p:spPr>
-        <p:txBody>
-          <a:bodyPr wrap="square" rtlCol="0" anchor="ctr"/>
-          <a:lstStyle/>
-          <a:p>
-            <a:pPr algn="ctr" indent="0" marL="0">
-              <a:buNone/>
-            </a:pPr>
-            <a:r>
-              <a:rPr lang="en-US" sz="900" dirty="0">
-                <a:solidFill>
-                  <a:srgbClr val="CBD5E1"/>
-                </a:solidFill>
-              </a:rPr>
-              <a:t>Core Service Areas</a:t>
-            </a:r>
-            <a:endParaRPr lang="en-US" sz="900" dirty="0"/>
-          </a:p>
-        </p:txBody>
-      </p:sp>
-      <p:sp>
-        <p:nvSpPr>
-          <p:cNvPr id="25" name="Shape 23"/>
-          <p:cNvSpPr/>
-          <p:nvPr/>
-        </p:nvSpPr>
-        <p:spPr>
-          <a:xfrm>
-            <a:off x="502920" y="3456432"/>
-            <a:ext cx="11183112" cy="36576"/>
-          </a:xfrm>
-          <a:prstGeom prst="rect">
-            <a:avLst/>
-          </a:prstGeom>
-          <a:solidFill>
-            <a:srgbClr val="5B21B6">
-              <a:alpha val="50000"/>
-            </a:srgbClr>
+          <p:cNvPr id="11" name="Shape 9"/>
+          <p:cNvSpPr/>
+          <p:nvPr/>
+        </p:nvSpPr>
+        <p:spPr>
+          <a:xfrm>
+            <a:off x="662940" y="1828800"/>
+            <a:ext cx="2084832" cy="54864"/>
+          </a:xfrm>
+          <a:prstGeom prst="rect">
+            <a:avLst/>
+          </a:prstGeom>
+          <a:solidFill>
+            <a:srgbClr val="7C3AED"/>
           </a:solidFill>
           <a:ln w="12700">
             <a:solidFill>
@@ -4304,56 +3820,121 @@
       </p:sp>
       <p:sp>
         <p:nvSpPr>
-          <p:cNvPr id="26" name="Text 24"/>
-          <p:cNvSpPr/>
-          <p:nvPr/>
-        </p:nvSpPr>
-        <p:spPr>
-          <a:xfrm>
-            <a:off x="502920" y="3566160"/>
-            <a:ext cx="11183112" cy="347472"/>
-          </a:xfrm>
-          <a:prstGeom prst="rect">
-            <a:avLst/>
-          </a:prstGeom>
-          <a:noFill/>
-          <a:ln/>
-        </p:spPr>
-        <p:txBody>
-          <a:bodyPr wrap="square" rtlCol="0" anchor="ctr"/>
-          <a:lstStyle/>
-          <a:p>
-            <a:pPr indent="0" marL="0">
-              <a:buNone/>
-            </a:pPr>
-            <a:r>
-              <a:rPr lang="en-US" sz="1700" b="1" dirty="0">
+          <p:cNvPr id="12" name="Text 10"/>
+          <p:cNvSpPr/>
+          <p:nvPr/>
+        </p:nvSpPr>
+        <p:spPr>
+          <a:xfrm>
+            <a:off x="662940" y="1920240"/>
+            <a:ext cx="2084832" cy="713232"/>
+          </a:xfrm>
+          <a:prstGeom prst="rect">
+            <a:avLst/>
+          </a:prstGeom>
+          <a:noFill/>
+          <a:ln/>
+        </p:spPr>
+        <p:txBody>
+          <a:bodyPr wrap="square" rtlCol="0" anchor="ctr"/>
+          <a:lstStyle/>
+          <a:p>
+            <a:pPr algn="ctr" indent="0" marL="0">
+              <a:buNone/>
+            </a:pPr>
+            <a:r>
+              <a:rPr lang="en-US" sz="3400" b="1" dirty="0">
                 <a:solidFill>
                   <a:srgbClr val="FFFFFF"/>
                 </a:solidFill>
               </a:rPr>
-              <a:t>Key Achievements</a:t>
-            </a:r>
-            <a:endParaRPr lang="en-US" sz="1700" dirty="0"/>
-          </a:p>
-        </p:txBody>
-      </p:sp>
-      <p:sp>
-        <p:nvSpPr>
-          <p:cNvPr id="27" name="Shape 25"/>
-          <p:cNvSpPr/>
-          <p:nvPr/>
-        </p:nvSpPr>
-        <p:spPr>
-          <a:xfrm>
-            <a:off x="502920" y="4050792"/>
-            <a:ext cx="91440" cy="91440"/>
-          </a:xfrm>
-          <a:prstGeom prst="ellipse">
-            <a:avLst/>
-          </a:prstGeom>
-          <a:solidFill>
-            <a:srgbClr val="A78BFA"/>
+              <a:t>5+</a:t>
+            </a:r>
+            <a:endParaRPr lang="en-US" sz="3400" dirty="0"/>
+          </a:p>
+        </p:txBody>
+      </p:sp>
+      <p:sp>
+        <p:nvSpPr>
+          <p:cNvPr id="13" name="Text 11"/>
+          <p:cNvSpPr/>
+          <p:nvPr/>
+        </p:nvSpPr>
+        <p:spPr>
+          <a:xfrm>
+            <a:off x="662940" y="2633472"/>
+            <a:ext cx="2084832" cy="530352"/>
+          </a:xfrm>
+          <a:prstGeom prst="rect">
+            <a:avLst/>
+          </a:prstGeom>
+          <a:noFill/>
+          <a:ln/>
+        </p:spPr>
+        <p:txBody>
+          <a:bodyPr wrap="square" rtlCol="0" anchor="ctr"/>
+          <a:lstStyle/>
+          <a:p>
+            <a:pPr algn="ctr" indent="0" marL="0">
+              <a:buNone/>
+            </a:pPr>
+            <a:r>
+              <a:rPr lang="en-US" sz="900" dirty="0">
+                <a:solidFill>
+                  <a:srgbClr val="E2E8F0"/>
+                </a:solidFill>
+              </a:rPr>
+              <a:t>Years of Excellence</a:t>
+            </a:r>
+            <a:endParaRPr lang="en-US" sz="900" dirty="0"/>
+          </a:p>
+        </p:txBody>
+      </p:sp>
+      <p:sp>
+        <p:nvSpPr>
+          <p:cNvPr id="14" name="Shape 12"/>
+          <p:cNvSpPr/>
+          <p:nvPr/>
+        </p:nvSpPr>
+        <p:spPr>
+          <a:xfrm>
+            <a:off x="2857500" y="1828800"/>
+            <a:ext cx="2084832" cy="1444752"/>
+          </a:xfrm>
+          <a:prstGeom prst="rect">
+            <a:avLst>
+              <a:gd name="adj" fmla="val 7595"/>
+            </a:avLst>
+          </a:prstGeom>
+          <a:solidFill>
+            <a:srgbClr val="1E1040"/>
+          </a:solidFill>
+          <a:ln w="12700">
+            <a:solidFill>
+              <a:srgbClr val="4F46E5">
+                <a:alpha val="80000"/>
+              </a:srgbClr>
+            </a:solidFill>
+            <a:prstDash val="solid"/>
+          </a:ln>
+        </p:spPr>
+      </p:sp>
+      <p:sp>
+        <p:nvSpPr>
+          <p:cNvPr id="15" name="Shape 13"/>
+          <p:cNvSpPr/>
+          <p:nvPr/>
+        </p:nvSpPr>
+        <p:spPr>
+          <a:xfrm>
+            <a:off x="2857500" y="1828800"/>
+            <a:ext cx="2084832" cy="54864"/>
+          </a:xfrm>
+          <a:prstGeom prst="rect">
+            <a:avLst/>
+          </a:prstGeom>
+          <a:solidFill>
+            <a:srgbClr val="4F46E5"/>
           </a:solidFill>
           <a:ln w="12700">
             <a:solidFill>
@@ -4367,56 +3948,121 @@
       </p:sp>
       <p:sp>
         <p:nvSpPr>
-          <p:cNvPr id="28" name="Text 26"/>
-          <p:cNvSpPr/>
-          <p:nvPr/>
-        </p:nvSpPr>
-        <p:spPr>
-          <a:xfrm>
-            <a:off x="685800" y="3986784"/>
-            <a:ext cx="5303520" cy="420624"/>
-          </a:xfrm>
-          <a:prstGeom prst="rect">
-            <a:avLst/>
-          </a:prstGeom>
-          <a:noFill/>
-          <a:ln/>
-        </p:spPr>
-        <p:txBody>
-          <a:bodyPr wrap="square" rtlCol="0" anchor="ctr"/>
-          <a:lstStyle/>
-          <a:p>
-            <a:pPr indent="0" marL="0">
-              <a:buNone/>
-            </a:pPr>
-            <a:r>
-              <a:rPr lang="en-US" sz="950" dirty="0">
+          <p:cNvPr id="16" name="Text 14"/>
+          <p:cNvSpPr/>
+          <p:nvPr/>
+        </p:nvSpPr>
+        <p:spPr>
+          <a:xfrm>
+            <a:off x="2857500" y="1920240"/>
+            <a:ext cx="2084832" cy="713232"/>
+          </a:xfrm>
+          <a:prstGeom prst="rect">
+            <a:avLst/>
+          </a:prstGeom>
+          <a:noFill/>
+          <a:ln/>
+        </p:spPr>
+        <p:txBody>
+          <a:bodyPr wrap="square" rtlCol="0" anchor="ctr"/>
+          <a:lstStyle/>
+          <a:p>
+            <a:pPr algn="ctr" indent="0" marL="0">
+              <a:buNone/>
+            </a:pPr>
+            <a:r>
+              <a:rPr lang="en-US" sz="3400" b="1" dirty="0">
+                <a:solidFill>
+                  <a:srgbClr val="FFFFFF"/>
+                </a:solidFill>
+              </a:rPr>
+              <a:t>5,000+</a:t>
+            </a:r>
+            <a:endParaRPr lang="en-US" sz="3400" dirty="0"/>
+          </a:p>
+        </p:txBody>
+      </p:sp>
+      <p:sp>
+        <p:nvSpPr>
+          <p:cNvPr id="17" name="Text 15"/>
+          <p:cNvSpPr/>
+          <p:nvPr/>
+        </p:nvSpPr>
+        <p:spPr>
+          <a:xfrm>
+            <a:off x="2857500" y="2633472"/>
+            <a:ext cx="2084832" cy="530352"/>
+          </a:xfrm>
+          <a:prstGeom prst="rect">
+            <a:avLst/>
+          </a:prstGeom>
+          <a:noFill/>
+          <a:ln/>
+        </p:spPr>
+        <p:txBody>
+          <a:bodyPr wrap="square" rtlCol="0" anchor="ctr"/>
+          <a:lstStyle/>
+          <a:p>
+            <a:pPr algn="ctr" indent="0" marL="0">
+              <a:buNone/>
+            </a:pPr>
+            <a:r>
+              <a:rPr lang="en-US" sz="900" dirty="0">
                 <a:solidFill>
                   <a:srgbClr val="E2E8F0"/>
                 </a:solidFill>
               </a:rPr>
-              <a:t>ISO 27001 certification programmes completed in under 9 months</a:t>
-            </a:r>
-            <a:endParaRPr lang="en-US" sz="950" dirty="0"/>
-          </a:p>
-        </p:txBody>
-      </p:sp>
-      <p:sp>
-        <p:nvSpPr>
-          <p:cNvPr id="29" name="Shape 27"/>
-          <p:cNvSpPr/>
-          <p:nvPr/>
-        </p:nvSpPr>
-        <p:spPr>
-          <a:xfrm>
-            <a:off x="6185916" y="4050792"/>
-            <a:ext cx="91440" cy="91440"/>
-          </a:xfrm>
-          <a:prstGeom prst="ellipse">
-            <a:avLst/>
-          </a:prstGeom>
-          <a:solidFill>
-            <a:srgbClr val="38BDF8"/>
+              <a:t>Projects Delivered</a:t>
+            </a:r>
+            <a:endParaRPr lang="en-US" sz="900" dirty="0"/>
+          </a:p>
+        </p:txBody>
+      </p:sp>
+      <p:sp>
+        <p:nvSpPr>
+          <p:cNvPr id="18" name="Shape 16"/>
+          <p:cNvSpPr/>
+          <p:nvPr/>
+        </p:nvSpPr>
+        <p:spPr>
+          <a:xfrm>
+            <a:off x="5052060" y="1828800"/>
+            <a:ext cx="2084832" cy="1444752"/>
+          </a:xfrm>
+          <a:prstGeom prst="rect">
+            <a:avLst>
+              <a:gd name="adj" fmla="val 7595"/>
+            </a:avLst>
+          </a:prstGeom>
+          <a:solidFill>
+            <a:srgbClr val="1E1040"/>
+          </a:solidFill>
+          <a:ln w="12700">
+            <a:solidFill>
+              <a:srgbClr val="0EA5E9">
+                <a:alpha val="80000"/>
+              </a:srgbClr>
+            </a:solidFill>
+            <a:prstDash val="solid"/>
+          </a:ln>
+        </p:spPr>
+      </p:sp>
+      <p:sp>
+        <p:nvSpPr>
+          <p:cNvPr id="19" name="Shape 17"/>
+          <p:cNvSpPr/>
+          <p:nvPr/>
+        </p:nvSpPr>
+        <p:spPr>
+          <a:xfrm>
+            <a:off x="5052060" y="1828800"/>
+            <a:ext cx="2084832" cy="54864"/>
+          </a:xfrm>
+          <a:prstGeom prst="rect">
+            <a:avLst/>
+          </a:prstGeom>
+          <a:solidFill>
+            <a:srgbClr val="0EA5E9"/>
           </a:solidFill>
           <a:ln w="12700">
             <a:solidFill>
@@ -4430,56 +4076,121 @@
       </p:sp>
       <p:sp>
         <p:nvSpPr>
-          <p:cNvPr id="30" name="Text 28"/>
-          <p:cNvSpPr/>
-          <p:nvPr/>
-        </p:nvSpPr>
-        <p:spPr>
-          <a:xfrm>
-            <a:off x="6368796" y="3986784"/>
-            <a:ext cx="5303520" cy="420624"/>
-          </a:xfrm>
-          <a:prstGeom prst="rect">
-            <a:avLst/>
-          </a:prstGeom>
-          <a:noFill/>
-          <a:ln/>
-        </p:spPr>
-        <p:txBody>
-          <a:bodyPr wrap="square" rtlCol="0" anchor="ctr"/>
-          <a:lstStyle/>
-          <a:p>
-            <a:pPr indent="0" marL="0">
-              <a:buNone/>
-            </a:pPr>
-            <a:r>
-              <a:rPr lang="en-US" sz="950" dirty="0">
+          <p:cNvPr id="20" name="Text 18"/>
+          <p:cNvSpPr/>
+          <p:nvPr/>
+        </p:nvSpPr>
+        <p:spPr>
+          <a:xfrm>
+            <a:off x="5052060" y="1920240"/>
+            <a:ext cx="2084832" cy="713232"/>
+          </a:xfrm>
+          <a:prstGeom prst="rect">
+            <a:avLst/>
+          </a:prstGeom>
+          <a:noFill/>
+          <a:ln/>
+        </p:spPr>
+        <p:txBody>
+          <a:bodyPr wrap="square" rtlCol="0" anchor="ctr"/>
+          <a:lstStyle/>
+          <a:p>
+            <a:pPr algn="ctr" indent="0" marL="0">
+              <a:buNone/>
+            </a:pPr>
+            <a:r>
+              <a:rPr lang="en-US" sz="3400" b="1" dirty="0">
+                <a:solidFill>
+                  <a:srgbClr val="FFFFFF"/>
+                </a:solidFill>
+              </a:rPr>
+              <a:t>1,000+</a:t>
+            </a:r>
+            <a:endParaRPr lang="en-US" sz="3400" dirty="0"/>
+          </a:p>
+        </p:txBody>
+      </p:sp>
+      <p:sp>
+        <p:nvSpPr>
+          <p:cNvPr id="21" name="Text 19"/>
+          <p:cNvSpPr/>
+          <p:nvPr/>
+        </p:nvSpPr>
+        <p:spPr>
+          <a:xfrm>
+            <a:off x="5052060" y="2633472"/>
+            <a:ext cx="2084832" cy="530352"/>
+          </a:xfrm>
+          <a:prstGeom prst="rect">
+            <a:avLst/>
+          </a:prstGeom>
+          <a:noFill/>
+          <a:ln/>
+        </p:spPr>
+        <p:txBody>
+          <a:bodyPr wrap="square" rtlCol="0" anchor="ctr"/>
+          <a:lstStyle/>
+          <a:p>
+            <a:pPr algn="ctr" indent="0" marL="0">
+              <a:buNone/>
+            </a:pPr>
+            <a:r>
+              <a:rPr lang="en-US" sz="900" dirty="0">
                 <a:solidFill>
                   <a:srgbClr val="E2E8F0"/>
                 </a:solidFill>
               </a:rPr>
-              <a:t>Zero-downtime cloud migrations delivered across financial sector clients</a:t>
-            </a:r>
-            <a:endParaRPr lang="en-US" sz="950" dirty="0"/>
-          </a:p>
-        </p:txBody>
-      </p:sp>
-      <p:sp>
-        <p:nvSpPr>
-          <p:cNvPr id="31" name="Shape 29"/>
-          <p:cNvSpPr/>
-          <p:nvPr/>
-        </p:nvSpPr>
-        <p:spPr>
-          <a:xfrm>
-            <a:off x="502920" y="4526280"/>
-            <a:ext cx="91440" cy="91440"/>
-          </a:xfrm>
-          <a:prstGeom prst="ellipse">
-            <a:avLst/>
-          </a:prstGeom>
-          <a:solidFill>
-            <a:srgbClr val="34D399"/>
+              <a:t>Clients Served</a:t>
+            </a:r>
+            <a:endParaRPr lang="en-US" sz="900" dirty="0"/>
+          </a:p>
+        </p:txBody>
+      </p:sp>
+      <p:sp>
+        <p:nvSpPr>
+          <p:cNvPr id="22" name="Shape 20"/>
+          <p:cNvSpPr/>
+          <p:nvPr/>
+        </p:nvSpPr>
+        <p:spPr>
+          <a:xfrm>
+            <a:off x="7246620" y="1828800"/>
+            <a:ext cx="2084832" cy="1444752"/>
+          </a:xfrm>
+          <a:prstGeom prst="rect">
+            <a:avLst>
+              <a:gd name="adj" fmla="val 7595"/>
+            </a:avLst>
+          </a:prstGeom>
+          <a:solidFill>
+            <a:srgbClr val="1E1040"/>
+          </a:solidFill>
+          <a:ln w="12700">
+            <a:solidFill>
+              <a:srgbClr val="059669">
+                <a:alpha val="80000"/>
+              </a:srgbClr>
+            </a:solidFill>
+            <a:prstDash val="solid"/>
+          </a:ln>
+        </p:spPr>
+      </p:sp>
+      <p:sp>
+        <p:nvSpPr>
+          <p:cNvPr id="23" name="Shape 21"/>
+          <p:cNvSpPr/>
+          <p:nvPr/>
+        </p:nvSpPr>
+        <p:spPr>
+          <a:xfrm>
+            <a:off x="7246620" y="1828800"/>
+            <a:ext cx="2084832" cy="54864"/>
+          </a:xfrm>
+          <a:prstGeom prst="rect">
+            <a:avLst/>
+          </a:prstGeom>
+          <a:solidFill>
+            <a:srgbClr val="059669"/>
           </a:solidFill>
           <a:ln w="12700">
             <a:solidFill>
@@ -4493,56 +4204,121 @@
       </p:sp>
       <p:sp>
         <p:nvSpPr>
-          <p:cNvPr id="32" name="Text 30"/>
-          <p:cNvSpPr/>
-          <p:nvPr/>
-        </p:nvSpPr>
-        <p:spPr>
-          <a:xfrm>
-            <a:off x="685800" y="4462272"/>
-            <a:ext cx="5303520" cy="420624"/>
-          </a:xfrm>
-          <a:prstGeom prst="rect">
-            <a:avLst/>
-          </a:prstGeom>
-          <a:noFill/>
-          <a:ln/>
-        </p:spPr>
-        <p:txBody>
-          <a:bodyPr wrap="square" rtlCol="0" anchor="ctr"/>
-          <a:lstStyle/>
-          <a:p>
-            <a:pPr indent="0" marL="0">
-              <a:buNone/>
-            </a:pPr>
-            <a:r>
-              <a:rPr lang="en-US" sz="950" dirty="0">
+          <p:cNvPr id="24" name="Text 22"/>
+          <p:cNvSpPr/>
+          <p:nvPr/>
+        </p:nvSpPr>
+        <p:spPr>
+          <a:xfrm>
+            <a:off x="7246620" y="1920240"/>
+            <a:ext cx="2084832" cy="713232"/>
+          </a:xfrm>
+          <a:prstGeom prst="rect">
+            <a:avLst/>
+          </a:prstGeom>
+          <a:noFill/>
+          <a:ln/>
+        </p:spPr>
+        <p:txBody>
+          <a:bodyPr wrap="square" rtlCol="0" anchor="ctr"/>
+          <a:lstStyle/>
+          <a:p>
+            <a:pPr algn="ctr" indent="0" marL="0">
+              <a:buNone/>
+            </a:pPr>
+            <a:r>
+              <a:rPr lang="en-US" sz="3400" b="1" dirty="0">
+                <a:solidFill>
+                  <a:srgbClr val="FFFFFF"/>
+                </a:solidFill>
+              </a:rPr>
+              <a:t>99.98%</a:t>
+            </a:r>
+            <a:endParaRPr lang="en-US" sz="3400" dirty="0"/>
+          </a:p>
+        </p:txBody>
+      </p:sp>
+      <p:sp>
+        <p:nvSpPr>
+          <p:cNvPr id="25" name="Text 23"/>
+          <p:cNvSpPr/>
+          <p:nvPr/>
+        </p:nvSpPr>
+        <p:spPr>
+          <a:xfrm>
+            <a:off x="7246620" y="2633472"/>
+            <a:ext cx="2084832" cy="530352"/>
+          </a:xfrm>
+          <a:prstGeom prst="rect">
+            <a:avLst/>
+          </a:prstGeom>
+          <a:noFill/>
+          <a:ln/>
+        </p:spPr>
+        <p:txBody>
+          <a:bodyPr wrap="square" rtlCol="0" anchor="ctr"/>
+          <a:lstStyle/>
+          <a:p>
+            <a:pPr algn="ctr" indent="0" marL="0">
+              <a:buNone/>
+            </a:pPr>
+            <a:r>
+              <a:rPr lang="en-US" sz="900" dirty="0">
                 <a:solidFill>
                   <a:srgbClr val="E2E8F0"/>
                 </a:solidFill>
               </a:rPr>
-              <a:t>Trusted technology partner for UAE Federal and Emirate Government entities</a:t>
-            </a:r>
-            <a:endParaRPr lang="en-US" sz="950" dirty="0"/>
-          </a:p>
-        </p:txBody>
-      </p:sp>
-      <p:sp>
-        <p:nvSpPr>
-          <p:cNvPr id="33" name="Shape 31"/>
-          <p:cNvSpPr/>
-          <p:nvPr/>
-        </p:nvSpPr>
-        <p:spPr>
-          <a:xfrm>
-            <a:off x="6185916" y="4526280"/>
-            <a:ext cx="91440" cy="91440"/>
-          </a:xfrm>
-          <a:prstGeom prst="ellipse">
-            <a:avLst/>
-          </a:prstGeom>
-          <a:solidFill>
-            <a:srgbClr val="FBB124"/>
+              <a:t>Average Uptime SLA</a:t>
+            </a:r>
+            <a:endParaRPr lang="en-US" sz="900" dirty="0"/>
+          </a:p>
+        </p:txBody>
+      </p:sp>
+      <p:sp>
+        <p:nvSpPr>
+          <p:cNvPr id="26" name="Shape 24"/>
+          <p:cNvSpPr/>
+          <p:nvPr/>
+        </p:nvSpPr>
+        <p:spPr>
+          <a:xfrm>
+            <a:off x="9441180" y="1828800"/>
+            <a:ext cx="2084832" cy="1444752"/>
+          </a:xfrm>
+          <a:prstGeom prst="rect">
+            <a:avLst>
+              <a:gd name="adj" fmla="val 7595"/>
+            </a:avLst>
+          </a:prstGeom>
+          <a:solidFill>
+            <a:srgbClr val="1E1040"/>
+          </a:solidFill>
+          <a:ln w="12700">
+            <a:solidFill>
+              <a:srgbClr val="D97706">
+                <a:alpha val="80000"/>
+              </a:srgbClr>
+            </a:solidFill>
+            <a:prstDash val="solid"/>
+          </a:ln>
+        </p:spPr>
+      </p:sp>
+      <p:sp>
+        <p:nvSpPr>
+          <p:cNvPr id="27" name="Shape 25"/>
+          <p:cNvSpPr/>
+          <p:nvPr/>
+        </p:nvSpPr>
+        <p:spPr>
+          <a:xfrm>
+            <a:off x="9441180" y="1828800"/>
+            <a:ext cx="2084832" cy="54864"/>
+          </a:xfrm>
+          <a:prstGeom prst="rect">
+            <a:avLst/>
+          </a:prstGeom>
+          <a:solidFill>
+            <a:srgbClr val="D97706"/>
           </a:solidFill>
           <a:ln w="12700">
             <a:solidFill>
@@ -4556,56 +4332,94 @@
       </p:sp>
       <p:sp>
         <p:nvSpPr>
-          <p:cNvPr id="34" name="Text 32"/>
-          <p:cNvSpPr/>
-          <p:nvPr/>
-        </p:nvSpPr>
-        <p:spPr>
-          <a:xfrm>
-            <a:off x="6368796" y="4462272"/>
-            <a:ext cx="5303520" cy="420624"/>
-          </a:xfrm>
-          <a:prstGeom prst="rect">
-            <a:avLst/>
-          </a:prstGeom>
-          <a:noFill/>
-          <a:ln/>
-        </p:spPr>
-        <p:txBody>
-          <a:bodyPr wrap="square" rtlCol="0" anchor="ctr"/>
-          <a:lstStyle/>
-          <a:p>
-            <a:pPr indent="0" marL="0">
-              <a:buNone/>
-            </a:pPr>
-            <a:r>
-              <a:rPr lang="en-US" sz="950" dirty="0">
+          <p:cNvPr id="28" name="Text 26"/>
+          <p:cNvSpPr/>
+          <p:nvPr/>
+        </p:nvSpPr>
+        <p:spPr>
+          <a:xfrm>
+            <a:off x="9441180" y="1920240"/>
+            <a:ext cx="2084832" cy="713232"/>
+          </a:xfrm>
+          <a:prstGeom prst="rect">
+            <a:avLst/>
+          </a:prstGeom>
+          <a:noFill/>
+          <a:ln/>
+        </p:spPr>
+        <p:txBody>
+          <a:bodyPr wrap="square" rtlCol="0" anchor="ctr"/>
+          <a:lstStyle/>
+          <a:p>
+            <a:pPr algn="ctr" indent="0" marL="0">
+              <a:buNone/>
+            </a:pPr>
+            <a:r>
+              <a:rPr lang="en-US" sz="3400" b="1" dirty="0">
+                <a:solidFill>
+                  <a:srgbClr val="FFFFFF"/>
+                </a:solidFill>
+              </a:rPr>
+              <a:t>8</a:t>
+            </a:r>
+            <a:endParaRPr lang="en-US" sz="3400" dirty="0"/>
+          </a:p>
+        </p:txBody>
+      </p:sp>
+      <p:sp>
+        <p:nvSpPr>
+          <p:cNvPr id="29" name="Text 27"/>
+          <p:cNvSpPr/>
+          <p:nvPr/>
+        </p:nvSpPr>
+        <p:spPr>
+          <a:xfrm>
+            <a:off x="9441180" y="2633472"/>
+            <a:ext cx="2084832" cy="530352"/>
+          </a:xfrm>
+          <a:prstGeom prst="rect">
+            <a:avLst/>
+          </a:prstGeom>
+          <a:noFill/>
+          <a:ln/>
+        </p:spPr>
+        <p:txBody>
+          <a:bodyPr wrap="square" rtlCol="0" anchor="ctr"/>
+          <a:lstStyle/>
+          <a:p>
+            <a:pPr algn="ctr" indent="0" marL="0">
+              <a:buNone/>
+            </a:pPr>
+            <a:r>
+              <a:rPr lang="en-US" sz="900" dirty="0">
                 <a:solidFill>
                   <a:srgbClr val="E2E8F0"/>
                 </a:solidFill>
               </a:rPr>
-              <a:t>Custom platforms serving 18,000+ daily active users across UAE university campuses</a:t>
-            </a:r>
-            <a:endParaRPr lang="en-US" sz="950" dirty="0"/>
-          </a:p>
-        </p:txBody>
-      </p:sp>
-      <p:sp>
-        <p:nvSpPr>
-          <p:cNvPr id="35" name="Shape 33"/>
-          <p:cNvSpPr/>
-          <p:nvPr/>
-        </p:nvSpPr>
-        <p:spPr>
-          <a:xfrm>
-            <a:off x="502920" y="5001768"/>
-            <a:ext cx="91440" cy="91440"/>
-          </a:xfrm>
-          <a:prstGeom prst="ellipse">
-            <a:avLst/>
-          </a:prstGeom>
-          <a:solidFill>
-            <a:srgbClr val="818CF8"/>
+              <a:t>Core Service Areas</a:t>
+            </a:r>
+            <a:endParaRPr lang="en-US" sz="900" dirty="0"/>
+          </a:p>
+        </p:txBody>
+      </p:sp>
+      <p:sp>
+        <p:nvSpPr>
+          <p:cNvPr id="30" name="Shape 28"/>
+          <p:cNvSpPr/>
+          <p:nvPr/>
+        </p:nvSpPr>
+        <p:spPr>
+          <a:xfrm>
+            <a:off x="502920" y="3456432"/>
+            <a:ext cx="11183112" cy="36576"/>
+          </a:xfrm>
+          <a:prstGeom prst="rect">
+            <a:avLst/>
+          </a:prstGeom>
+          <a:solidFill>
+            <a:srgbClr val="FFFFFF">
+              <a:alpha val="30000"/>
+            </a:srgbClr>
           </a:solidFill>
           <a:ln w="12700">
             <a:solidFill>
@@ -4619,56 +4433,56 @@
       </p:sp>
       <p:sp>
         <p:nvSpPr>
-          <p:cNvPr id="36" name="Text 34"/>
-          <p:cNvSpPr/>
-          <p:nvPr/>
-        </p:nvSpPr>
-        <p:spPr>
-          <a:xfrm>
-            <a:off x="685800" y="4937760"/>
-            <a:ext cx="5303520" cy="420624"/>
-          </a:xfrm>
-          <a:prstGeom prst="rect">
-            <a:avLst/>
-          </a:prstGeom>
-          <a:noFill/>
-          <a:ln/>
-        </p:spPr>
-        <p:txBody>
-          <a:bodyPr wrap="square" rtlCol="0" anchor="ctr"/>
-          <a:lstStyle/>
-          <a:p>
-            <a:pPr indent="0" marL="0">
-              <a:buNone/>
-            </a:pPr>
-            <a:r>
-              <a:rPr lang="en-US" sz="950" dirty="0">
-                <a:solidFill>
-                  <a:srgbClr val="E2E8F0"/>
-                </a:solidFill>
-              </a:rPr>
-              <a:t>Real-time BI platforms deployed across 80+ retail locations in the Gulf region</a:t>
-            </a:r>
-            <a:endParaRPr lang="en-US" sz="950" dirty="0"/>
-          </a:p>
-        </p:txBody>
-      </p:sp>
-      <p:sp>
-        <p:nvSpPr>
-          <p:cNvPr id="37" name="Shape 35"/>
-          <p:cNvSpPr/>
-          <p:nvPr/>
-        </p:nvSpPr>
-        <p:spPr>
-          <a:xfrm>
-            <a:off x="6185916" y="5001768"/>
+          <p:cNvPr id="31" name="Text 29"/>
+          <p:cNvSpPr/>
+          <p:nvPr/>
+        </p:nvSpPr>
+        <p:spPr>
+          <a:xfrm>
+            <a:off x="502920" y="3566160"/>
+            <a:ext cx="11183112" cy="347472"/>
+          </a:xfrm>
+          <a:prstGeom prst="rect">
+            <a:avLst/>
+          </a:prstGeom>
+          <a:noFill/>
+          <a:ln/>
+        </p:spPr>
+        <p:txBody>
+          <a:bodyPr wrap="square" rtlCol="0" anchor="ctr"/>
+          <a:lstStyle/>
+          <a:p>
+            <a:pPr indent="0" marL="0">
+              <a:buNone/>
+            </a:pPr>
+            <a:r>
+              <a:rPr lang="en-US" sz="1700" b="1" dirty="0">
+                <a:solidFill>
+                  <a:srgbClr val="FFFFFF"/>
+                </a:solidFill>
+              </a:rPr>
+              <a:t>Key Achievements</a:t>
+            </a:r>
+            <a:endParaRPr lang="en-US" sz="1700" dirty="0"/>
+          </a:p>
+        </p:txBody>
+      </p:sp>
+      <p:sp>
+        <p:nvSpPr>
+          <p:cNvPr id="32" name="Shape 30"/>
+          <p:cNvSpPr/>
+          <p:nvPr/>
+        </p:nvSpPr>
+        <p:spPr>
+          <a:xfrm>
+            <a:off x="502920" y="4050792"/>
             <a:ext cx="91440" cy="91440"/>
           </a:xfrm>
           <a:prstGeom prst="ellipse">
             <a:avLst/>
           </a:prstGeom>
           <a:solidFill>
-            <a:srgbClr val="F87171"/>
+            <a:srgbClr val="A78BFA"/>
           </a:solidFill>
           <a:ln w="12700">
             <a:solidFill>
@@ -4682,13 +4496,13 @@
       </p:sp>
       <p:sp>
         <p:nvSpPr>
-          <p:cNvPr id="38" name="Text 36"/>
-          <p:cNvSpPr/>
-          <p:nvPr/>
-        </p:nvSpPr>
-        <p:spPr>
-          <a:xfrm>
-            <a:off x="6368796" y="4937760"/>
+          <p:cNvPr id="33" name="Text 31"/>
+          <p:cNvSpPr/>
+          <p:nvPr/>
+        </p:nvSpPr>
+        <p:spPr>
+          <a:xfrm>
+            <a:off x="685800" y="3986784"/>
             <a:ext cx="5303520" cy="420624"/>
           </a:xfrm>
           <a:prstGeom prst="rect">
@@ -4707,10 +4521,10 @@
             <a:r>
               <a:rPr lang="en-US" sz="950" dirty="0">
                 <a:solidFill>
-                  <a:srgbClr val="E2E8F0"/>
-                </a:solidFill>
-              </a:rPr>
-              <a:t>AI-powered SaaS HR platform reaching 5,000 active users within 6 months of launch</a:t>
+                  <a:srgbClr val="FFFFFF"/>
+                </a:solidFill>
+              </a:rPr>
+              <a:t>ISO 27001 certification programmes completed in under 9 months</a:t>
             </a:r>
             <a:endParaRPr lang="en-US" sz="950" dirty="0"/>
           </a:p>
@@ -4718,22 +4532,20 @@
       </p:sp>
       <p:sp>
         <p:nvSpPr>
-          <p:cNvPr id="39" name="Shape 37"/>
-          <p:cNvSpPr/>
-          <p:nvPr/>
-        </p:nvSpPr>
-        <p:spPr>
-          <a:xfrm>
-            <a:off x="0" y="6565392"/>
-            <a:ext cx="12192000" cy="292608"/>
-          </a:xfrm>
-          <a:prstGeom prst="rect">
-            <a:avLst/>
-          </a:prstGeom>
-          <a:solidFill>
-            <a:srgbClr val="3B0764">
-              <a:alpha val="60000"/>
-            </a:srgbClr>
+          <p:cNvPr id="34" name="Shape 32"/>
+          <p:cNvSpPr/>
+          <p:nvPr/>
+        </p:nvSpPr>
+        <p:spPr>
+          <a:xfrm>
+            <a:off x="6185916" y="4050792"/>
+            <a:ext cx="91440" cy="91440"/>
+          </a:xfrm>
+          <a:prstGeom prst="ellipse">
+            <a:avLst/>
+          </a:prstGeom>
+          <a:solidFill>
+            <a:srgbClr val="38BDF8"/>
           </a:solidFill>
           <a:ln w="12700">
             <a:solidFill>
@@ -4747,7 +4559,295 @@
       </p:sp>
       <p:sp>
         <p:nvSpPr>
-          <p:cNvPr id="40" name="Text 38"/>
+          <p:cNvPr id="35" name="Text 33"/>
+          <p:cNvSpPr/>
+          <p:nvPr/>
+        </p:nvSpPr>
+        <p:spPr>
+          <a:xfrm>
+            <a:off x="6368796" y="3986784"/>
+            <a:ext cx="5303520" cy="420624"/>
+          </a:xfrm>
+          <a:prstGeom prst="rect">
+            <a:avLst/>
+          </a:prstGeom>
+          <a:noFill/>
+          <a:ln/>
+        </p:spPr>
+        <p:txBody>
+          <a:bodyPr wrap="square" rtlCol="0" anchor="ctr"/>
+          <a:lstStyle/>
+          <a:p>
+            <a:pPr indent="0" marL="0">
+              <a:buNone/>
+            </a:pPr>
+            <a:r>
+              <a:rPr lang="en-US" sz="950" dirty="0">
+                <a:solidFill>
+                  <a:srgbClr val="FFFFFF"/>
+                </a:solidFill>
+              </a:rPr>
+              <a:t>Zero-downtime cloud migrations delivered across financial sector clients</a:t>
+            </a:r>
+            <a:endParaRPr lang="en-US" sz="950" dirty="0"/>
+          </a:p>
+        </p:txBody>
+      </p:sp>
+      <p:sp>
+        <p:nvSpPr>
+          <p:cNvPr id="36" name="Shape 34"/>
+          <p:cNvSpPr/>
+          <p:nvPr/>
+        </p:nvSpPr>
+        <p:spPr>
+          <a:xfrm>
+            <a:off x="502920" y="4526280"/>
+            <a:ext cx="91440" cy="91440"/>
+          </a:xfrm>
+          <a:prstGeom prst="ellipse">
+            <a:avLst/>
+          </a:prstGeom>
+          <a:solidFill>
+            <a:srgbClr val="34D399"/>
+          </a:solidFill>
+          <a:ln w="12700">
+            <a:solidFill>
+              <a:srgbClr val="333333">
+                <a:alpha val="0"/>
+              </a:srgbClr>
+            </a:solidFill>
+            <a:prstDash val="solid"/>
+          </a:ln>
+        </p:spPr>
+      </p:sp>
+      <p:sp>
+        <p:nvSpPr>
+          <p:cNvPr id="37" name="Text 35"/>
+          <p:cNvSpPr/>
+          <p:nvPr/>
+        </p:nvSpPr>
+        <p:spPr>
+          <a:xfrm>
+            <a:off x="685800" y="4462272"/>
+            <a:ext cx="5303520" cy="420624"/>
+          </a:xfrm>
+          <a:prstGeom prst="rect">
+            <a:avLst/>
+          </a:prstGeom>
+          <a:noFill/>
+          <a:ln/>
+        </p:spPr>
+        <p:txBody>
+          <a:bodyPr wrap="square" rtlCol="0" anchor="ctr"/>
+          <a:lstStyle/>
+          <a:p>
+            <a:pPr indent="0" marL="0">
+              <a:buNone/>
+            </a:pPr>
+            <a:r>
+              <a:rPr lang="en-US" sz="950" dirty="0">
+                <a:solidFill>
+                  <a:srgbClr val="FFFFFF"/>
+                </a:solidFill>
+              </a:rPr>
+              <a:t>Trusted technology partner for UAE Federal and Emirate Government entities</a:t>
+            </a:r>
+            <a:endParaRPr lang="en-US" sz="950" dirty="0"/>
+          </a:p>
+        </p:txBody>
+      </p:sp>
+      <p:sp>
+        <p:nvSpPr>
+          <p:cNvPr id="38" name="Shape 36"/>
+          <p:cNvSpPr/>
+          <p:nvPr/>
+        </p:nvSpPr>
+        <p:spPr>
+          <a:xfrm>
+            <a:off x="6185916" y="4526280"/>
+            <a:ext cx="91440" cy="91440"/>
+          </a:xfrm>
+          <a:prstGeom prst="ellipse">
+            <a:avLst/>
+          </a:prstGeom>
+          <a:solidFill>
+            <a:srgbClr val="FBBF24"/>
+          </a:solidFill>
+          <a:ln w="12700">
+            <a:solidFill>
+              <a:srgbClr val="333333">
+                <a:alpha val="0"/>
+              </a:srgbClr>
+            </a:solidFill>
+            <a:prstDash val="solid"/>
+          </a:ln>
+        </p:spPr>
+      </p:sp>
+      <p:sp>
+        <p:nvSpPr>
+          <p:cNvPr id="39" name="Text 37"/>
+          <p:cNvSpPr/>
+          <p:nvPr/>
+        </p:nvSpPr>
+        <p:spPr>
+          <a:xfrm>
+            <a:off x="6368796" y="4462272"/>
+            <a:ext cx="5303520" cy="420624"/>
+          </a:xfrm>
+          <a:prstGeom prst="rect">
+            <a:avLst/>
+          </a:prstGeom>
+          <a:noFill/>
+          <a:ln/>
+        </p:spPr>
+        <p:txBody>
+          <a:bodyPr wrap="square" rtlCol="0" anchor="ctr"/>
+          <a:lstStyle/>
+          <a:p>
+            <a:pPr indent="0" marL="0">
+              <a:buNone/>
+            </a:pPr>
+            <a:r>
+              <a:rPr lang="en-US" sz="950" dirty="0">
+                <a:solidFill>
+                  <a:srgbClr val="FFFFFF"/>
+                </a:solidFill>
+              </a:rPr>
+              <a:t>Custom platforms serving 18,000+ daily active users across UAE university campuses</a:t>
+            </a:r>
+            <a:endParaRPr lang="en-US" sz="950" dirty="0"/>
+          </a:p>
+        </p:txBody>
+      </p:sp>
+      <p:sp>
+        <p:nvSpPr>
+          <p:cNvPr id="40" name="Shape 38"/>
+          <p:cNvSpPr/>
+          <p:nvPr/>
+        </p:nvSpPr>
+        <p:spPr>
+          <a:xfrm>
+            <a:off x="502920" y="5001768"/>
+            <a:ext cx="91440" cy="91440"/>
+          </a:xfrm>
+          <a:prstGeom prst="ellipse">
+            <a:avLst/>
+          </a:prstGeom>
+          <a:solidFill>
+            <a:srgbClr val="818CF8"/>
+          </a:solidFill>
+          <a:ln w="12700">
+            <a:solidFill>
+              <a:srgbClr val="333333">
+                <a:alpha val="0"/>
+              </a:srgbClr>
+            </a:solidFill>
+            <a:prstDash val="solid"/>
+          </a:ln>
+        </p:spPr>
+      </p:sp>
+      <p:sp>
+        <p:nvSpPr>
+          <p:cNvPr id="41" name="Text 39"/>
+          <p:cNvSpPr/>
+          <p:nvPr/>
+        </p:nvSpPr>
+        <p:spPr>
+          <a:xfrm>
+            <a:off x="685800" y="4937760"/>
+            <a:ext cx="5303520" cy="420624"/>
+          </a:xfrm>
+          <a:prstGeom prst="rect">
+            <a:avLst/>
+          </a:prstGeom>
+          <a:noFill/>
+          <a:ln/>
+        </p:spPr>
+        <p:txBody>
+          <a:bodyPr wrap="square" rtlCol="0" anchor="ctr"/>
+          <a:lstStyle/>
+          <a:p>
+            <a:pPr indent="0" marL="0">
+              <a:buNone/>
+            </a:pPr>
+            <a:r>
+              <a:rPr lang="en-US" sz="950" dirty="0">
+                <a:solidFill>
+                  <a:srgbClr val="FFFFFF"/>
+                </a:solidFill>
+              </a:rPr>
+              <a:t>Real-time BI platforms deployed across 80+ retail locations in the Gulf region</a:t>
+            </a:r>
+            <a:endParaRPr lang="en-US" sz="950" dirty="0"/>
+          </a:p>
+        </p:txBody>
+      </p:sp>
+      <p:sp>
+        <p:nvSpPr>
+          <p:cNvPr id="42" name="Shape 40"/>
+          <p:cNvSpPr/>
+          <p:nvPr/>
+        </p:nvSpPr>
+        <p:spPr>
+          <a:xfrm>
+            <a:off x="6185916" y="5001768"/>
+            <a:ext cx="91440" cy="91440"/>
+          </a:xfrm>
+          <a:prstGeom prst="ellipse">
+            <a:avLst/>
+          </a:prstGeom>
+          <a:solidFill>
+            <a:srgbClr val="F87171"/>
+          </a:solidFill>
+          <a:ln w="12700">
+            <a:solidFill>
+              <a:srgbClr val="333333">
+                <a:alpha val="0"/>
+              </a:srgbClr>
+            </a:solidFill>
+            <a:prstDash val="solid"/>
+          </a:ln>
+        </p:spPr>
+      </p:sp>
+      <p:sp>
+        <p:nvSpPr>
+          <p:cNvPr id="43" name="Text 41"/>
+          <p:cNvSpPr/>
+          <p:nvPr/>
+        </p:nvSpPr>
+        <p:spPr>
+          <a:xfrm>
+            <a:off x="6368796" y="4937760"/>
+            <a:ext cx="5303520" cy="420624"/>
+          </a:xfrm>
+          <a:prstGeom prst="rect">
+            <a:avLst/>
+          </a:prstGeom>
+          <a:noFill/>
+          <a:ln/>
+        </p:spPr>
+        <p:txBody>
+          <a:bodyPr wrap="square" rtlCol="0" anchor="ctr"/>
+          <a:lstStyle/>
+          <a:p>
+            <a:pPr indent="0" marL="0">
+              <a:buNone/>
+            </a:pPr>
+            <a:r>
+              <a:rPr lang="en-US" sz="950" dirty="0">
+                <a:solidFill>
+                  <a:srgbClr val="FFFFFF"/>
+                </a:solidFill>
+              </a:rPr>
+              <a:t>AI-powered SaaS HR platform reaching 5,000 active users within 6 months of launch</a:t>
+            </a:r>
+            <a:endParaRPr lang="en-US" sz="950" dirty="0"/>
+          </a:p>
+        </p:txBody>
+      </p:sp>
+      <p:sp>
+        <p:nvSpPr>
+          <p:cNvPr id="44" name="Shape 42"/>
           <p:cNvSpPr/>
           <p:nvPr/>
         </p:nvSpPr>
@@ -4759,6 +4859,33 @@
           <a:prstGeom prst="rect">
             <a:avLst/>
           </a:prstGeom>
+          <a:solidFill>
+            <a:srgbClr val="1E1040"/>
+          </a:solidFill>
+          <a:ln w="12700">
+            <a:solidFill>
+              <a:srgbClr val="333333">
+                <a:alpha val="0"/>
+              </a:srgbClr>
+            </a:solidFill>
+            <a:prstDash val="solid"/>
+          </a:ln>
+        </p:spPr>
+      </p:sp>
+      <p:sp>
+        <p:nvSpPr>
+          <p:cNvPr id="45" name="Text 43"/>
+          <p:cNvSpPr/>
+          <p:nvPr/>
+        </p:nvSpPr>
+        <p:spPr>
+          <a:xfrm>
+            <a:off x="0" y="6565392"/>
+            <a:ext cx="12192000" cy="292608"/>
+          </a:xfrm>
+          <a:prstGeom prst="rect">
+            <a:avLst/>
+          </a:prstGeom>
           <a:noFill/>
           <a:ln/>
         </p:spPr>
@@ -4772,7 +4899,7 @@
             <a:r>
               <a:rPr lang="en-US" sz="750" dirty="0">
                 <a:solidFill>
-                  <a:srgbClr val="C4B5FD"/>
+                  <a:srgbClr val="E9D5FF"/>
                 </a:solidFill>
               </a:rPr>
               <a:t>WeThink Technology Consulting  ·  Abu Dhabi, UAE  ·  wethink.ae  ·  © 2025</a:t>
@@ -4820,6 +4947,9 @@
           <a:prstGeom prst="rect">
             <a:avLst/>
           </a:prstGeom>
+          <a:solidFill>
+            <a:srgbClr val="0C0818"/>
+          </a:solidFill>
           <a:ln/>
         </p:spPr>
       </p:sp>
@@ -5041,7 +5171,7 @@
             <a:r>
               <a:rPr lang="en-US" sz="1000" dirty="0">
                 <a:solidFill>
-                  <a:srgbClr val="D8B4FE"/>
+                  <a:srgbClr val="E9D5FF"/>
                 </a:solidFill>
               </a:rPr>
               <a:t>Reach out and let's start a conversation.</a:t>
@@ -5113,7 +5243,7 @@
             <a:r>
               <a:rPr lang="en-US" sz="1300" b="1" dirty="0">
                 <a:solidFill>
-                  <a:srgbClr val="C4B5FD"/>
+                  <a:srgbClr val="E9D5FF"/>
                 </a:solidFill>
               </a:rPr>
               <a:t>WeThink Technology Consulting</a:t>
@@ -5139,14 +5269,12 @@
             </a:avLst>
           </a:prstGeom>
           <a:solidFill>
-            <a:srgbClr val="FFFFFF">
-              <a:alpha val="12000"/>
-            </a:srgbClr>
+            <a:srgbClr val="1E1040"/>
           </a:solidFill>
           <a:ln w="12700">
             <a:solidFill>
-              <a:srgbClr val="A78BFA">
-                <a:alpha val="45000"/>
+              <a:srgbClr val="7C3AED">
+                <a:alpha val="70000"/>
               </a:srgbClr>
             </a:solidFill>
             <a:prstDash val="solid"/>
@@ -5207,7 +5335,7 @@
             <a:r>
               <a:rPr lang="en-US" sz="750" b="1" spc="150" kern="0" dirty="0">
                 <a:solidFill>
-                  <a:srgbClr val="D8B4FE"/>
+                  <a:srgbClr val="E9D5FF"/>
                 </a:solidFill>
               </a:rPr>
               <a:t>WEBSITE</a:t>
@@ -5269,14 +5397,12 @@
             </a:avLst>
           </a:prstGeom>
           <a:solidFill>
-            <a:srgbClr val="FFFFFF">
-              <a:alpha val="12000"/>
-            </a:srgbClr>
+            <a:srgbClr val="1E1040"/>
           </a:solidFill>
           <a:ln w="12700">
             <a:solidFill>
-              <a:srgbClr val="A78BFA">
-                <a:alpha val="45000"/>
+              <a:srgbClr val="7C3AED">
+                <a:alpha val="70000"/>
               </a:srgbClr>
             </a:solidFill>
             <a:prstDash val="solid"/>
@@ -5337,7 +5463,7 @@
             <a:r>
               <a:rPr lang="en-US" sz="750" b="1" spc="150" kern="0" dirty="0">
                 <a:solidFill>
-                  <a:srgbClr val="D8B4FE"/>
+                  <a:srgbClr val="E9D5FF"/>
                 </a:solidFill>
               </a:rPr>
               <a:t>EMAIL</a:t>
@@ -5399,14 +5525,12 @@
             </a:avLst>
           </a:prstGeom>
           <a:solidFill>
-            <a:srgbClr val="FFFFFF">
-              <a:alpha val="12000"/>
-            </a:srgbClr>
+            <a:srgbClr val="1E1040"/>
           </a:solidFill>
           <a:ln w="12700">
             <a:solidFill>
-              <a:srgbClr val="A78BFA">
-                <a:alpha val="45000"/>
+              <a:srgbClr val="7C3AED">
+                <a:alpha val="70000"/>
               </a:srgbClr>
             </a:solidFill>
             <a:prstDash val="solid"/>
@@ -5467,7 +5591,7 @@
             <a:r>
               <a:rPr lang="en-US" sz="750" b="1" spc="150" kern="0" dirty="0">
                 <a:solidFill>
-                  <a:srgbClr val="D8B4FE"/>
+                  <a:srgbClr val="E9D5FF"/>
                 </a:solidFill>
               </a:rPr>
               <a:t>LOCATION</a:t>
@@ -5529,14 +5653,12 @@
             </a:avLst>
           </a:prstGeom>
           <a:solidFill>
-            <a:srgbClr val="FFFFFF">
-              <a:alpha val="12000"/>
-            </a:srgbClr>
+            <a:srgbClr val="1E1040"/>
           </a:solidFill>
           <a:ln w="12700">
             <a:solidFill>
-              <a:srgbClr val="A78BFA">
-                <a:alpha val="45000"/>
+              <a:srgbClr val="7C3AED">
+                <a:alpha val="70000"/>
               </a:srgbClr>
             </a:solidFill>
             <a:prstDash val="solid"/>
@@ -5597,7 +5719,7 @@
             <a:r>
               <a:rPr lang="en-US" sz="750" b="1" spc="150" kern="0" dirty="0">
                 <a:solidFill>
-                  <a:srgbClr val="D8B4FE"/>
+                  <a:srgbClr val="E9D5FF"/>
                 </a:solidFill>
               </a:rPr>
               <a:t>ESTABLISHED</a:t>
@@ -5669,7 +5791,7 @@
             <a:r>
               <a:rPr lang="en-US" sz="750" b="1" spc="150" kern="0" dirty="0">
                 <a:solidFill>
-                  <a:srgbClr val="A78BFA"/>
+                  <a:srgbClr val="E9D5FF"/>
                 </a:solidFill>
               </a:rPr>
               <a:t>SERVICES</a:t>
@@ -5705,7 +5827,7 @@
             <a:r>
               <a:rPr lang="en-US" sz="850" dirty="0">
                 <a:solidFill>
-                  <a:srgbClr val="CBD5E1"/>
+                  <a:srgbClr val="E2E8F0"/>
                 </a:solidFill>
               </a:rPr>
               <a:t>IT Consulting  ·  Cloud Strategy  ·  Cybersecurity  ·  Custom Software  ·  Data Analytics  ·  Digital Transformation</a:t>
@@ -5791,9 +5913,7 @@
             <a:avLst/>
           </a:prstGeom>
           <a:solidFill>
-            <a:srgbClr val="3B0764">
-              <a:alpha val="60000"/>
-            </a:srgbClr>
+            <a:srgbClr val="1E1040"/>
           </a:solidFill>
           <a:ln w="12700">
             <a:solidFill>
@@ -5832,7 +5952,7 @@
             <a:r>
               <a:rPr lang="en-US" sz="750" dirty="0">
                 <a:solidFill>
-                  <a:srgbClr val="C4B5FD"/>
+                  <a:srgbClr val="E9D5FF"/>
                 </a:solidFill>
               </a:rPr>
               <a:t>WeThink Technology Consulting  ·  Abu Dhabi, UAE  ·  wethink.ae  ·  © 2025</a:t>

</xml_diff>